<commit_message>
add  code and files and fix bugs
</commit_message>
<xml_diff>
--- a/day_23/day_23.pptx
+++ b/day_23/day_23.pptx
@@ -34021,7 +34021,7 @@
         <p:spPr>
           <a:xfrm>
             <a:off x="256032" y="1463040"/>
-            <a:ext cx="8229600" cy="2677656"/>
+            <a:ext cx="8229600" cy="2676525"/>
           </a:xfrm>
           <a:prstGeom prst="rect">
             <a:avLst/>
@@ -34051,7 +34051,16 @@
                 </a:solidFill>
                 <a:latin typeface="Source Code Pro"/>
               </a:rPr>
-              <a:t>Linear</a:t>
+              <a:t>L</a:t>
+            </a:r>
+            <a:r>
+              <a:rPr lang="en-US" sz="1400" b="1" dirty="0">
+                <a:solidFill>
+                  <a:schemeClr val="accent3"/>
+                </a:solidFill>
+                <a:latin typeface="Source Code Pro"/>
+              </a:rPr>
+              <a:t>ogistic</a:t>
             </a:r>
             <a:r>
               <a:rPr sz="1400" dirty="0">
@@ -34357,7 +34366,7 @@
         <p:spPr>
           <a:xfrm>
             <a:off x="457199" y="365760"/>
-            <a:ext cx="11587655" cy="584775"/>
+            <a:ext cx="11587655" cy="583565"/>
           </a:xfrm>
           <a:prstGeom prst="rect">
             <a:avLst/>
@@ -34378,7 +34387,25 @@
                 </a:solidFill>
                 <a:latin typeface="Source Code Pro"/>
               </a:rPr>
-              <a:t>Why Linear Regression Fails at Classification</a:t>
+              <a:t>Why </a:t>
+            </a:r>
+            <a:r>
+              <a:rPr lang="en-US" sz="3200" b="0" dirty="0">
+                <a:solidFill>
+                  <a:srgbClr val="FFFFFF"/>
+                </a:solidFill>
+                <a:latin typeface="Source Code Pro"/>
+              </a:rPr>
+              <a:t>Logistic </a:t>
+            </a:r>
+            <a:r>
+              <a:rPr sz="3200" b="0" dirty="0">
+                <a:solidFill>
+                  <a:srgbClr val="FFFFFF"/>
+                </a:solidFill>
+                <a:latin typeface="Source Code Pro"/>
+              </a:rPr>
+              <a:t>Regression Fails at Classification</a:t>
             </a:r>
             <a:endParaRPr sz="3200" b="0" dirty="0">
               <a:solidFill>
@@ -34398,7 +34425,7 @@
         <p:spPr>
           <a:xfrm>
             <a:off x="256032" y="1463040"/>
-            <a:ext cx="8229600" cy="2893100"/>
+            <a:ext cx="8229600" cy="2891790"/>
           </a:xfrm>
           <a:prstGeom prst="rect">
             <a:avLst/>
@@ -34422,13 +34449,14 @@
           <a:p>
             <a:pPr algn="l"/>
             <a:r>
-              <a:rPr sz="1400" dirty="0">
-                <a:solidFill>
-                  <a:srgbClr val="E7E7E7"/>
+              <a:rPr lang="en-US" sz="1400" dirty="0">
+                <a:solidFill>
+                  <a:srgbClr val="FFFFFF"/>
                 </a:solidFill>
                 <a:latin typeface="Source Code Pro"/>
+                <a:sym typeface="+mn-ea"/>
               </a:rPr>
-              <a:t>Linear </a:t>
+              <a:t>Logistic </a:t>
             </a:r>
             <a:r>
               <a:rPr sz="1400" b="1" dirty="0">

</xml_diff>